<commit_message>
Add OAK depth logging and llama examples
</commit_message>
<xml_diff>
--- a/presentation/export/gemma4_oak_obstacle_presentation_editable_shapes.pptx
+++ b/presentation/export/gemma4_oak_obstacle_presentation_editable_shapes.pptx
@@ -16,6 +16,7 @@
     <p:sldId id="264" r:id="rId15"/>
     <p:sldId id="265" r:id="rId16"/>
     <p:sldId id="266" r:id="rId17"/>
+    <p:sldId id="267" r:id="rId18"/>
   </p:sldIdLst>
   <p:sldSz cx="12191695" cy="6858000" type="screen4x3"/>
   <p:notesSz cx="6858000" cy="9144000"/>
@@ -3867,7 +3868,7 @@
                 </a:solidFill>
                 <a:latin typeface="NanumSquare Bold"/>
               </a:rPr>
-              <a:t>한계와 다음 단계</a:t>
+              <a:t>이 기술이 어디에서 쓰이면 좋은가</a:t>
             </a:r>
           </a:p>
         </p:txBody>
@@ -3902,7 +3903,7 @@
                 </a:solidFill>
                 <a:latin typeface="NanumBarunGothic"/>
               </a:rPr>
-              <a:t>현재 기준선에서 추가로 보강할 부분</a:t>
+              <a:t>환자이송 로봇의 실제 운영 시나리오</a:t>
             </a:r>
           </a:p>
         </p:txBody>
@@ -3916,13 +3917,13 @@
         <p:spPr>
           <a:xfrm>
             <a:off x="658368" y="164592"/>
-            <a:ext cx="1463040" cy="310896"/>
+            <a:ext cx="1417320" cy="310896"/>
           </a:xfrm>
           <a:prstGeom prst="roundRect">
             <a:avLst/>
           </a:prstGeom>
           <a:solidFill>
-            <a:srgbClr val="1B6EF3"/>
+            <a:srgbClr val="0F9D58"/>
           </a:solidFill>
           <a:ln>
             <a:noFill/>
@@ -3954,7 +3955,7 @@
                 </a:solidFill>
                 <a:latin typeface="Noto Sans CJK KR"/>
               </a:rPr>
-              <a:t>Next Step</a:t>
+              <a:t>Use Cases</a:t>
             </a:r>
           </a:p>
         </p:txBody>
@@ -3967,8 +3968,8 @@
         </p:nvSpPr>
         <p:spPr>
           <a:xfrm>
-            <a:off x="731520" y="1417320"/>
-            <a:ext cx="5303520" cy="4526280"/>
+            <a:off x="713232" y="1417320"/>
+            <a:ext cx="3154680" cy="4526280"/>
           </a:xfrm>
           <a:prstGeom prst="roundRect">
             <a:avLst/>
@@ -4012,8 +4013,156 @@
         </p:nvSpPr>
         <p:spPr>
           <a:xfrm>
-            <a:off x="6172200" y="1417320"/>
-            <a:ext cx="5303520" cy="4526280"/>
+            <a:off x="877824" y="1600200"/>
+            <a:ext cx="1325880" cy="329184"/>
+          </a:xfrm>
+          <a:prstGeom prst="roundRect">
+            <a:avLst/>
+          </a:prstGeom>
+          <a:solidFill>
+            <a:srgbClr val="1B6EF3"/>
+          </a:solidFill>
+          <a:ln>
+            <a:noFill/>
+          </a:ln>
+        </p:spPr>
+        <p:style>
+          <a:lnRef idx="1">
+            <a:schemeClr val="accent1"/>
+          </a:lnRef>
+          <a:fillRef idx="3">
+            <a:schemeClr val="accent1"/>
+          </a:fillRef>
+          <a:effectRef idx="2">
+            <a:schemeClr val="accent1"/>
+          </a:effectRef>
+          <a:fontRef idx="minor">
+            <a:schemeClr val="lt1"/>
+          </a:fontRef>
+        </p:style>
+        <p:txBody>
+          <a:bodyPr rtlCol="0" anchor="ctr"/>
+          <a:lstStyle/>
+          <a:p>
+            <a:pPr algn="ctr"/>
+            <a:r>
+              <a:rPr sz="1100" b="1">
+                <a:solidFill>
+                  <a:srgbClr val="FFFFFF"/>
+                </a:solidFill>
+                <a:latin typeface="Noto Sans CJK KR"/>
+              </a:rPr>
+              <a:t>병실 출입 및 퇴실</a:t>
+            </a:r>
+          </a:p>
+        </p:txBody>
+      </p:sp>
+      <p:sp>
+        <p:nvSpPr>
+          <p:cNvPr id="7" name="TextBox 6"/>
+          <p:cNvSpPr txBox="1"/>
+          <p:nvPr/>
+        </p:nvSpPr>
+        <p:spPr>
+          <a:xfrm>
+            <a:off x="877824" y="2084831"/>
+            <a:ext cx="2788920" cy="1783080"/>
+          </a:xfrm>
+          <a:prstGeom prst="rect">
+            <a:avLst/>
+          </a:prstGeom>
+          <a:noFill/>
+        </p:spPr>
+        <p:txBody>
+          <a:bodyPr wrap="square" lIns="0" rIns="0" tIns="0" bIns="0">
+            <a:spAutoFit/>
+          </a:bodyPr>
+          <a:lstStyle/>
+          <a:p>
+            <a:pPr>
+              <a:lnSpc>
+                <a:spcPct val="115000"/>
+              </a:lnSpc>
+              <a:spcAft>
+                <a:spcPts val="800"/>
+              </a:spcAft>
+            </a:pPr>
+            <a:r>
+              <a:rPr sz="1400" b="0">
+                <a:solidFill>
+                  <a:srgbClr val="17212B"/>
+                </a:solidFill>
+                <a:latin typeface="Noto Sans CJK KR"/>
+              </a:rPr>
+              <a:t>• 전방 휠체어와 IV pole을 인식하고 안전거리 확보 후 진입한다.</a:t>
+            </a:r>
+          </a:p>
+          <a:p>
+            <a:pPr>
+              <a:lnSpc>
+                <a:spcPct val="115000"/>
+              </a:lnSpc>
+              <a:spcAft>
+                <a:spcPts val="800"/>
+              </a:spcAft>
+            </a:pPr>
+            <a:r>
+              <a:rPr sz="1400" b="0">
+                <a:solidFill>
+                  <a:srgbClr val="17212B"/>
+                </a:solidFill>
+                <a:latin typeface="Noto Sans CJK KR"/>
+              </a:rPr>
+              <a:t>• 병실 내부 침대 주변 가구를 보고 회전 반경을 보수적으로 잡는다.</a:t>
+            </a:r>
+          </a:p>
+        </p:txBody>
+      </p:sp>
+      <p:sp>
+        <p:nvSpPr>
+          <p:cNvPr id="8" name="TextBox 7"/>
+          <p:cNvSpPr txBox="1"/>
+          <p:nvPr/>
+        </p:nvSpPr>
+        <p:spPr>
+          <a:xfrm>
+            <a:off x="877824" y="4224528"/>
+            <a:ext cx="2788920" cy="1353312"/>
+          </a:xfrm>
+          <a:prstGeom prst="rect">
+            <a:avLst/>
+          </a:prstGeom>
+          <a:noFill/>
+        </p:spPr>
+        <p:txBody>
+          <a:bodyPr wrap="square">
+            <a:spAutoFit/>
+          </a:bodyPr>
+          <a:lstStyle/>
+          <a:p>
+            <a:pPr algn="l"/>
+            <a:r>
+              <a:rPr sz="1200" b="0">
+                <a:solidFill>
+                  <a:srgbClr val="5A6777"/>
+                </a:solidFill>
+                <a:latin typeface="NanumBarunGothic"/>
+              </a:rPr>
+              <a:t>예시 안내: “전방에 휠체어가 있습니다. 잠시 경로를 조정하겠습니다.”</a:t>
+            </a:r>
+          </a:p>
+        </p:txBody>
+      </p:sp>
+      <p:sp>
+        <p:nvSpPr>
+          <p:cNvPr id="9" name="Rounded Rectangle 8"/>
+          <p:cNvSpPr/>
+          <p:nvPr/>
+        </p:nvSpPr>
+        <p:spPr>
+          <a:xfrm>
+            <a:off x="4096512" y="1417320"/>
+            <a:ext cx="3154680" cy="4526280"/>
           </a:xfrm>
           <a:prstGeom prst="roundRect">
             <a:avLst/>
@@ -4051,48 +4200,66 @@
       </p:sp>
       <p:sp>
         <p:nvSpPr>
-          <p:cNvPr id="7" name="TextBox 6"/>
+          <p:cNvPr id="10" name="Rounded Rectangle 9"/>
+          <p:cNvSpPr/>
+          <p:nvPr/>
+        </p:nvSpPr>
+        <p:spPr>
+          <a:xfrm>
+            <a:off x="4261104" y="1600200"/>
+            <a:ext cx="1325880" cy="329184"/>
+          </a:xfrm>
+          <a:prstGeom prst="roundRect">
+            <a:avLst/>
+          </a:prstGeom>
+          <a:solidFill>
+            <a:srgbClr val="E85D3F"/>
+          </a:solidFill>
+          <a:ln>
+            <a:noFill/>
+          </a:ln>
+        </p:spPr>
+        <p:style>
+          <a:lnRef idx="1">
+            <a:schemeClr val="accent1"/>
+          </a:lnRef>
+          <a:fillRef idx="3">
+            <a:schemeClr val="accent1"/>
+          </a:fillRef>
+          <a:effectRef idx="2">
+            <a:schemeClr val="accent1"/>
+          </a:effectRef>
+          <a:fontRef idx="minor">
+            <a:schemeClr val="lt1"/>
+          </a:fontRef>
+        </p:style>
+        <p:txBody>
+          <a:bodyPr rtlCol="0" anchor="ctr"/>
+          <a:lstStyle/>
+          <a:p>
+            <a:pPr algn="ctr"/>
+            <a:r>
+              <a:rPr sz="1100" b="1">
+                <a:solidFill>
+                  <a:srgbClr val="FFFFFF"/>
+                </a:solidFill>
+                <a:latin typeface="Noto Sans CJK KR"/>
+              </a:rPr>
+              <a:t>복도 주행 및 양보</a:t>
+            </a:r>
+          </a:p>
+        </p:txBody>
+      </p:sp>
+      <p:sp>
+        <p:nvSpPr>
+          <p:cNvPr id="11" name="TextBox 10"/>
           <p:cNvSpPr txBox="1"/>
           <p:nvPr/>
         </p:nvSpPr>
         <p:spPr>
           <a:xfrm>
-            <a:off x="960120" y="1691640"/>
-            <a:ext cx="2560320" cy="320040"/>
-          </a:xfrm>
-          <a:prstGeom prst="rect">
-            <a:avLst/>
-          </a:prstGeom>
-          <a:noFill/>
-        </p:spPr>
-        <p:txBody>
-          <a:bodyPr wrap="none">
-            <a:spAutoFit/>
-          </a:bodyPr>
-          <a:lstStyle/>
-          <a:p>
-            <a:r>
-              <a:rPr sz="2000" b="1">
-                <a:solidFill>
-                  <a:srgbClr val="17212B"/>
-                </a:solidFill>
-                <a:latin typeface="NanumSquare Bold"/>
-              </a:rPr>
-              <a:t>현재 한계</a:t>
-            </a:r>
-          </a:p>
-        </p:txBody>
-      </p:sp>
-      <p:sp>
-        <p:nvSpPr>
-          <p:cNvPr id="8" name="TextBox 7"/>
-          <p:cNvSpPr txBox="1"/>
-          <p:nvPr/>
-        </p:nvSpPr>
-        <p:spPr>
-          <a:xfrm>
-            <a:off x="960120" y="2176272"/>
-            <a:ext cx="4663440" cy="1965960"/>
+            <a:off x="4261104" y="2084831"/>
+            <a:ext cx="2788920" cy="1783080"/>
           </a:xfrm>
           <a:prstGeom prst="rect">
             <a:avLst/>
@@ -4114,13 +4281,13 @@
               </a:spcAft>
             </a:pPr>
             <a:r>
-              <a:rPr sz="1600" b="0">
+              <a:rPr sz="1400" b="0">
                 <a:solidFill>
                   <a:srgbClr val="17212B"/>
                 </a:solidFill>
                 <a:latin typeface="Noto Sans CJK KR"/>
               </a:rPr>
-              <a:t>• VLM 기반이라 누락과 과추론 가능성이 있다.</a:t>
+              <a:t>• 복도에서 의료진, 보호자, 이동식 카트를 구분해 우선순위를 판단한다.</a:t>
             </a:r>
           </a:p>
           <a:p>
@@ -4133,15 +4300,170 @@
               </a:spcAft>
             </a:pPr>
             <a:r>
-              <a:rPr sz="1600" b="0">
+              <a:rPr sz="1400" b="0">
                 <a:solidFill>
                   <a:srgbClr val="17212B"/>
                 </a:solidFill>
                 <a:latin typeface="Noto Sans CJK KR"/>
               </a:rPr>
-              <a:t>• 장면이 복잡하면 객체 수를 완전히 세지 못할 수 있다.</a:t>
-            </a:r>
-          </a:p>
+              <a:t>• 사람이 지나가는 동안 일시 정지하거나 벽 쪽으로 붙는 동작에 활용할 수 있다.</a:t>
+            </a:r>
+          </a:p>
+        </p:txBody>
+      </p:sp>
+      <p:sp>
+        <p:nvSpPr>
+          <p:cNvPr id="12" name="TextBox 11"/>
+          <p:cNvSpPr txBox="1"/>
+          <p:nvPr/>
+        </p:nvSpPr>
+        <p:spPr>
+          <a:xfrm>
+            <a:off x="4261104" y="4224528"/>
+            <a:ext cx="2788920" cy="1353312"/>
+          </a:xfrm>
+          <a:prstGeom prst="rect">
+            <a:avLst/>
+          </a:prstGeom>
+          <a:noFill/>
+        </p:spPr>
+        <p:txBody>
+          <a:bodyPr wrap="square">
+            <a:spAutoFit/>
+          </a:bodyPr>
+          <a:lstStyle/>
+          <a:p>
+            <a:pPr algn="l"/>
+            <a:r>
+              <a:rPr sz="1200" b="0">
+                <a:solidFill>
+                  <a:srgbClr val="5A6777"/>
+                </a:solidFill>
+                <a:latin typeface="NanumBarunGothic"/>
+              </a:rPr>
+              <a:t>예시 안내: “파란 가운을 입은 의료진이 지나가는 중입니다. 잠시 대기 후 이동하겠습니다.”</a:t>
+            </a:r>
+          </a:p>
+        </p:txBody>
+      </p:sp>
+      <p:sp>
+        <p:nvSpPr>
+          <p:cNvPr id="13" name="Rounded Rectangle 12"/>
+          <p:cNvSpPr/>
+          <p:nvPr/>
+        </p:nvSpPr>
+        <p:spPr>
+          <a:xfrm>
+            <a:off x="7479792" y="1417320"/>
+            <a:ext cx="3154680" cy="4526280"/>
+          </a:xfrm>
+          <a:prstGeom prst="roundRect">
+            <a:avLst/>
+          </a:prstGeom>
+          <a:solidFill>
+            <a:srgbClr val="FFFFFF"/>
+          </a:solidFill>
+          <a:ln w="12700">
+            <a:solidFill>
+              <a:srgbClr val="D8DEE8"/>
+            </a:solidFill>
+          </a:ln>
+        </p:spPr>
+        <p:style>
+          <a:lnRef idx="1">
+            <a:schemeClr val="accent1"/>
+          </a:lnRef>
+          <a:fillRef idx="3">
+            <a:schemeClr val="accent1"/>
+          </a:fillRef>
+          <a:effectRef idx="2">
+            <a:schemeClr val="accent1"/>
+          </a:effectRef>
+          <a:fontRef idx="minor">
+            <a:schemeClr val="lt1"/>
+          </a:fontRef>
+        </p:style>
+        <p:txBody>
+          <a:bodyPr rtlCol="0" anchor="ctr"/>
+          <a:lstStyle/>
+          <a:p>
+            <a:pPr algn="ctr"/>
+          </a:p>
+        </p:txBody>
+      </p:sp>
+      <p:sp>
+        <p:nvSpPr>
+          <p:cNvPr id="14" name="Rounded Rectangle 13"/>
+          <p:cNvSpPr/>
+          <p:nvPr/>
+        </p:nvSpPr>
+        <p:spPr>
+          <a:xfrm>
+            <a:off x="7644383" y="1600200"/>
+            <a:ext cx="1325880" cy="329184"/>
+          </a:xfrm>
+          <a:prstGeom prst="roundRect">
+            <a:avLst/>
+          </a:prstGeom>
+          <a:solidFill>
+            <a:srgbClr val="0F9D58"/>
+          </a:solidFill>
+          <a:ln>
+            <a:noFill/>
+          </a:ln>
+        </p:spPr>
+        <p:style>
+          <a:lnRef idx="1">
+            <a:schemeClr val="accent1"/>
+          </a:lnRef>
+          <a:fillRef idx="3">
+            <a:schemeClr val="accent1"/>
+          </a:fillRef>
+          <a:effectRef idx="2">
+            <a:schemeClr val="accent1"/>
+          </a:effectRef>
+          <a:fontRef idx="minor">
+            <a:schemeClr val="lt1"/>
+          </a:fontRef>
+        </p:style>
+        <p:txBody>
+          <a:bodyPr rtlCol="0" anchor="ctr"/>
+          <a:lstStyle/>
+          <a:p>
+            <a:pPr algn="ctr"/>
+            <a:r>
+              <a:rPr sz="1100" b="1">
+                <a:solidFill>
+                  <a:srgbClr val="FFFFFF"/>
+                </a:solidFill>
+                <a:latin typeface="Noto Sans CJK KR"/>
+              </a:rPr>
+              <a:t>중앙 관제·재경로</a:t>
+            </a:r>
+          </a:p>
+        </p:txBody>
+      </p:sp>
+      <p:sp>
+        <p:nvSpPr>
+          <p:cNvPr id="15" name="TextBox 14"/>
+          <p:cNvSpPr txBox="1"/>
+          <p:nvPr/>
+        </p:nvSpPr>
+        <p:spPr>
+          <a:xfrm>
+            <a:off x="7644383" y="2084831"/>
+            <a:ext cx="2788920" cy="1783080"/>
+          </a:xfrm>
+          <a:prstGeom prst="rect">
+            <a:avLst/>
+          </a:prstGeom>
+          <a:noFill/>
+        </p:spPr>
+        <p:txBody>
+          <a:bodyPr wrap="square" lIns="0" rIns="0" tIns="0" bIns="0">
+            <a:spAutoFit/>
+          </a:bodyPr>
+          <a:lstStyle/>
           <a:p>
             <a:pPr>
               <a:lnSpc>
@@ -4152,72 +4474,15 @@
               </a:spcAft>
             </a:pPr>
             <a:r>
-              <a:rPr sz="1600" b="0">
+              <a:rPr sz="1400" b="0">
                 <a:solidFill>
                   <a:srgbClr val="17212B"/>
                 </a:solidFill>
                 <a:latin typeface="Noto Sans CJK KR"/>
               </a:rPr>
-              <a:t>• 정밀 bbox detector 수준의 좌표는 아니다.</a:t>
-            </a:r>
-          </a:p>
-        </p:txBody>
-      </p:sp>
-      <p:sp>
-        <p:nvSpPr>
-          <p:cNvPr id="9" name="TextBox 8"/>
-          <p:cNvSpPr txBox="1"/>
-          <p:nvPr/>
-        </p:nvSpPr>
-        <p:spPr>
-          <a:xfrm>
-            <a:off x="6400800" y="1691640"/>
-            <a:ext cx="2560320" cy="320040"/>
-          </a:xfrm>
-          <a:prstGeom prst="rect">
-            <a:avLst/>
-          </a:prstGeom>
-          <a:noFill/>
-        </p:spPr>
-        <p:txBody>
-          <a:bodyPr wrap="none">
-            <a:spAutoFit/>
-          </a:bodyPr>
-          <a:lstStyle/>
-          <a:p>
-            <a:r>
-              <a:rPr sz="2000" b="1">
-                <a:solidFill>
-                  <a:srgbClr val="17212B"/>
-                </a:solidFill>
-                <a:latin typeface="NanumSquare Bold"/>
-              </a:rPr>
-              <a:t>다음 단계</a:t>
-            </a:r>
-          </a:p>
-        </p:txBody>
-      </p:sp>
-      <p:sp>
-        <p:nvSpPr>
-          <p:cNvPr id="10" name="TextBox 9"/>
-          <p:cNvSpPr txBox="1"/>
-          <p:nvPr/>
-        </p:nvSpPr>
-        <p:spPr>
-          <a:xfrm>
-            <a:off x="6400800" y="2176272"/>
-            <a:ext cx="4663440" cy="1965960"/>
-          </a:xfrm>
-          <a:prstGeom prst="rect">
-            <a:avLst/>
-          </a:prstGeom>
-          <a:noFill/>
-        </p:spPr>
-        <p:txBody>
-          <a:bodyPr wrap="square" lIns="0" rIns="0" tIns="0" bIns="0">
-            <a:spAutoFit/>
-          </a:bodyPr>
-          <a:lstStyle/>
+              <a:t>• 장애물 클래스와 거리 정보를 서버로 보내 동선 혼잡도를 기록할 수 있다.</a:t>
+            </a:r>
+          </a:p>
           <a:p>
             <a:pPr>
               <a:lnSpc>
@@ -4228,51 +4493,48 @@
               </a:spcAft>
             </a:pPr>
             <a:r>
-              <a:rPr sz="1600" b="0">
+              <a:rPr sz="1400" b="0">
                 <a:solidFill>
                   <a:srgbClr val="17212B"/>
                 </a:solidFill>
                 <a:latin typeface="Noto Sans CJK KR"/>
               </a:rPr>
-              <a:t>• detector/grounding 모델을 병행해 좌표 정밀도를 높인다.</a:t>
-            </a:r>
-          </a:p>
-          <a:p>
-            <a:pPr>
-              <a:lnSpc>
-                <a:spcPct val="115000"/>
-              </a:lnSpc>
-              <a:spcAft>
-                <a:spcPts val="800"/>
-              </a:spcAft>
-            </a:pPr>
-            <a:r>
-              <a:rPr sz="1600" b="0">
-                <a:solidFill>
-                  <a:srgbClr val="17212B"/>
-                </a:solidFill>
-                <a:latin typeface="Noto Sans CJK KR"/>
-              </a:rPr>
-              <a:t>• 장애물 taxonomy를 환자이송 로봇 운영 기준으로 더 정제한다.</a:t>
-            </a:r>
-          </a:p>
-          <a:p>
-            <a:pPr>
-              <a:lnSpc>
-                <a:spcPct val="115000"/>
-              </a:lnSpc>
-              <a:spcAft>
-                <a:spcPts val="800"/>
-              </a:spcAft>
-            </a:pPr>
-            <a:r>
-              <a:rPr sz="1600" b="0">
-                <a:solidFill>
-                  <a:srgbClr val="17212B"/>
-                </a:solidFill>
-                <a:latin typeface="Noto Sans CJK KR"/>
-              </a:rPr>
-              <a:t>• OAK depth를 실시간 주행 제어와 연결한다.</a:t>
+              <a:t>• 병동별 잦은 장애물 패턴을 보고 재경로 정책을 보강할 수 있다.</a:t>
+            </a:r>
+          </a:p>
+        </p:txBody>
+      </p:sp>
+      <p:sp>
+        <p:nvSpPr>
+          <p:cNvPr id="16" name="TextBox 15"/>
+          <p:cNvSpPr txBox="1"/>
+          <p:nvPr/>
+        </p:nvSpPr>
+        <p:spPr>
+          <a:xfrm>
+            <a:off x="7644383" y="4224528"/>
+            <a:ext cx="2788920" cy="1353312"/>
+          </a:xfrm>
+          <a:prstGeom prst="rect">
+            <a:avLst/>
+          </a:prstGeom>
+          <a:noFill/>
+        </p:spPr>
+        <p:txBody>
+          <a:bodyPr wrap="square">
+            <a:spAutoFit/>
+          </a:bodyPr>
+          <a:lstStyle/>
+          <a:p>
+            <a:pPr algn="l"/>
+            <a:r>
+              <a:rPr sz="1200" b="0">
+                <a:solidFill>
+                  <a:srgbClr val="5A6777"/>
+                </a:solidFill>
+                <a:latin typeface="NanumBarunGothic"/>
+              </a:rPr>
+              <a:t>예시 안내: “전방 2.8m 지점에 이동 장애물이 있습니다. 우회 경로를 탐색합니다.”</a:t>
             </a:r>
           </a:p>
         </p:txBody>
@@ -4286,6 +4548,472 @@
 </file>
 
 <file path=ppt/slides/slide11.xml><?xml version="1.0" encoding="utf-8"?>
+<p:sld xmlns:a="http://schemas.openxmlformats.org/drawingml/2006/main" xmlns:p="http://schemas.openxmlformats.org/presentationml/2006/main" xmlns:r="http://schemas.openxmlformats.org/officeDocument/2006/relationships">
+  <p:cSld>
+    <p:bg>
+      <p:bgPr>
+        <a:solidFill>
+          <a:srgbClr val="F7F6F3"/>
+        </a:solidFill>
+        <a:effectLst/>
+      </p:bgPr>
+    </p:bg>
+    <p:spTree>
+      <p:nvGrpSpPr>
+        <p:cNvPr id="1" name=""/>
+        <p:cNvGrpSpPr/>
+        <p:nvPr/>
+      </p:nvGrpSpPr>
+      <p:grpSpPr/>
+      <p:sp>
+        <p:nvSpPr>
+          <p:cNvPr id="2" name="TextBox 1"/>
+          <p:cNvSpPr txBox="1"/>
+          <p:nvPr/>
+        </p:nvSpPr>
+        <p:spPr>
+          <a:xfrm>
+            <a:off x="676656" y="347472"/>
+            <a:ext cx="10789920" cy="658368"/>
+          </a:xfrm>
+          <a:prstGeom prst="rect">
+            <a:avLst/>
+          </a:prstGeom>
+          <a:noFill/>
+        </p:spPr>
+        <p:txBody>
+          <a:bodyPr wrap="square">
+            <a:spAutoFit/>
+          </a:bodyPr>
+          <a:lstStyle/>
+          <a:p>
+            <a:pPr algn="ctr"/>
+            <a:r>
+              <a:rPr sz="2600" b="1">
+                <a:solidFill>
+                  <a:srgbClr val="17212B"/>
+                </a:solidFill>
+                <a:latin typeface="NanumSquare Bold"/>
+              </a:rPr>
+              <a:t>한계와 다음 단계</a:t>
+            </a:r>
+          </a:p>
+        </p:txBody>
+      </p:sp>
+      <p:sp>
+        <p:nvSpPr>
+          <p:cNvPr id="3" name="TextBox 2"/>
+          <p:cNvSpPr txBox="1"/>
+          <p:nvPr/>
+        </p:nvSpPr>
+        <p:spPr>
+          <a:xfrm>
+            <a:off x="1097280" y="914400"/>
+            <a:ext cx="9966960" cy="320040"/>
+          </a:xfrm>
+          <a:prstGeom prst="rect">
+            <a:avLst/>
+          </a:prstGeom>
+          <a:noFill/>
+        </p:spPr>
+        <p:txBody>
+          <a:bodyPr wrap="none">
+            <a:spAutoFit/>
+          </a:bodyPr>
+          <a:lstStyle/>
+          <a:p>
+            <a:pPr algn="ctr"/>
+            <a:r>
+              <a:rPr sz="1200" b="0">
+                <a:solidFill>
+                  <a:srgbClr val="5A6777"/>
+                </a:solidFill>
+                <a:latin typeface="NanumBarunGothic"/>
+              </a:rPr>
+              <a:t>현재 기준선에서 추가로 보강할 부분</a:t>
+            </a:r>
+          </a:p>
+        </p:txBody>
+      </p:sp>
+      <p:sp>
+        <p:nvSpPr>
+          <p:cNvPr id="4" name="Rounded Rectangle 3"/>
+          <p:cNvSpPr/>
+          <p:nvPr/>
+        </p:nvSpPr>
+        <p:spPr>
+          <a:xfrm>
+            <a:off x="658368" y="164592"/>
+            <a:ext cx="1463040" cy="310896"/>
+          </a:xfrm>
+          <a:prstGeom prst="roundRect">
+            <a:avLst/>
+          </a:prstGeom>
+          <a:solidFill>
+            <a:srgbClr val="1B6EF3"/>
+          </a:solidFill>
+          <a:ln>
+            <a:noFill/>
+          </a:ln>
+        </p:spPr>
+        <p:style>
+          <a:lnRef idx="1">
+            <a:schemeClr val="accent1"/>
+          </a:lnRef>
+          <a:fillRef idx="3">
+            <a:schemeClr val="accent1"/>
+          </a:fillRef>
+          <a:effectRef idx="2">
+            <a:schemeClr val="accent1"/>
+          </a:effectRef>
+          <a:fontRef idx="minor">
+            <a:schemeClr val="lt1"/>
+          </a:fontRef>
+        </p:style>
+        <p:txBody>
+          <a:bodyPr rtlCol="0" anchor="ctr"/>
+          <a:lstStyle/>
+          <a:p>
+            <a:pPr algn="ctr"/>
+            <a:r>
+              <a:rPr sz="1100" b="1">
+                <a:solidFill>
+                  <a:srgbClr val="FFFFFF"/>
+                </a:solidFill>
+                <a:latin typeface="Noto Sans CJK KR"/>
+              </a:rPr>
+              <a:t>Next Step</a:t>
+            </a:r>
+          </a:p>
+        </p:txBody>
+      </p:sp>
+      <p:sp>
+        <p:nvSpPr>
+          <p:cNvPr id="5" name="Rounded Rectangle 4"/>
+          <p:cNvSpPr/>
+          <p:nvPr/>
+        </p:nvSpPr>
+        <p:spPr>
+          <a:xfrm>
+            <a:off x="731520" y="1417320"/>
+            <a:ext cx="5303520" cy="4526280"/>
+          </a:xfrm>
+          <a:prstGeom prst="roundRect">
+            <a:avLst/>
+          </a:prstGeom>
+          <a:solidFill>
+            <a:srgbClr val="FFFFFF"/>
+          </a:solidFill>
+          <a:ln w="12700">
+            <a:solidFill>
+              <a:srgbClr val="D8DEE8"/>
+            </a:solidFill>
+          </a:ln>
+        </p:spPr>
+        <p:style>
+          <a:lnRef idx="1">
+            <a:schemeClr val="accent1"/>
+          </a:lnRef>
+          <a:fillRef idx="3">
+            <a:schemeClr val="accent1"/>
+          </a:fillRef>
+          <a:effectRef idx="2">
+            <a:schemeClr val="accent1"/>
+          </a:effectRef>
+          <a:fontRef idx="minor">
+            <a:schemeClr val="lt1"/>
+          </a:fontRef>
+        </p:style>
+        <p:txBody>
+          <a:bodyPr rtlCol="0" anchor="ctr"/>
+          <a:lstStyle/>
+          <a:p>
+            <a:pPr algn="ctr"/>
+          </a:p>
+        </p:txBody>
+      </p:sp>
+      <p:sp>
+        <p:nvSpPr>
+          <p:cNvPr id="6" name="Rounded Rectangle 5"/>
+          <p:cNvSpPr/>
+          <p:nvPr/>
+        </p:nvSpPr>
+        <p:spPr>
+          <a:xfrm>
+            <a:off x="6172200" y="1417320"/>
+            <a:ext cx="5303520" cy="4526280"/>
+          </a:xfrm>
+          <a:prstGeom prst="roundRect">
+            <a:avLst/>
+          </a:prstGeom>
+          <a:solidFill>
+            <a:srgbClr val="FFFFFF"/>
+          </a:solidFill>
+          <a:ln w="12700">
+            <a:solidFill>
+              <a:srgbClr val="D8DEE8"/>
+            </a:solidFill>
+          </a:ln>
+        </p:spPr>
+        <p:style>
+          <a:lnRef idx="1">
+            <a:schemeClr val="accent1"/>
+          </a:lnRef>
+          <a:fillRef idx="3">
+            <a:schemeClr val="accent1"/>
+          </a:fillRef>
+          <a:effectRef idx="2">
+            <a:schemeClr val="accent1"/>
+          </a:effectRef>
+          <a:fontRef idx="minor">
+            <a:schemeClr val="lt1"/>
+          </a:fontRef>
+        </p:style>
+        <p:txBody>
+          <a:bodyPr rtlCol="0" anchor="ctr"/>
+          <a:lstStyle/>
+          <a:p>
+            <a:pPr algn="ctr"/>
+          </a:p>
+        </p:txBody>
+      </p:sp>
+      <p:sp>
+        <p:nvSpPr>
+          <p:cNvPr id="7" name="TextBox 6"/>
+          <p:cNvSpPr txBox="1"/>
+          <p:nvPr/>
+        </p:nvSpPr>
+        <p:spPr>
+          <a:xfrm>
+            <a:off x="960120" y="1691640"/>
+            <a:ext cx="2560320" cy="320040"/>
+          </a:xfrm>
+          <a:prstGeom prst="rect">
+            <a:avLst/>
+          </a:prstGeom>
+          <a:noFill/>
+        </p:spPr>
+        <p:txBody>
+          <a:bodyPr wrap="none">
+            <a:spAutoFit/>
+          </a:bodyPr>
+          <a:lstStyle/>
+          <a:p>
+            <a:r>
+              <a:rPr sz="2000" b="1">
+                <a:solidFill>
+                  <a:srgbClr val="17212B"/>
+                </a:solidFill>
+                <a:latin typeface="NanumSquare Bold"/>
+              </a:rPr>
+              <a:t>현재 한계</a:t>
+            </a:r>
+          </a:p>
+        </p:txBody>
+      </p:sp>
+      <p:sp>
+        <p:nvSpPr>
+          <p:cNvPr id="8" name="TextBox 7"/>
+          <p:cNvSpPr txBox="1"/>
+          <p:nvPr/>
+        </p:nvSpPr>
+        <p:spPr>
+          <a:xfrm>
+            <a:off x="960120" y="2176272"/>
+            <a:ext cx="4663440" cy="1965960"/>
+          </a:xfrm>
+          <a:prstGeom prst="rect">
+            <a:avLst/>
+          </a:prstGeom>
+          <a:noFill/>
+        </p:spPr>
+        <p:txBody>
+          <a:bodyPr wrap="square" lIns="0" rIns="0" tIns="0" bIns="0">
+            <a:spAutoFit/>
+          </a:bodyPr>
+          <a:lstStyle/>
+          <a:p>
+            <a:pPr>
+              <a:lnSpc>
+                <a:spcPct val="115000"/>
+              </a:lnSpc>
+              <a:spcAft>
+                <a:spcPts val="800"/>
+              </a:spcAft>
+            </a:pPr>
+            <a:r>
+              <a:rPr sz="1600" b="0">
+                <a:solidFill>
+                  <a:srgbClr val="17212B"/>
+                </a:solidFill>
+                <a:latin typeface="Noto Sans CJK KR"/>
+              </a:rPr>
+              <a:t>• VLM 기반이라 누락과 과추론 가능성이 있다.</a:t>
+            </a:r>
+          </a:p>
+          <a:p>
+            <a:pPr>
+              <a:lnSpc>
+                <a:spcPct val="115000"/>
+              </a:lnSpc>
+              <a:spcAft>
+                <a:spcPts val="800"/>
+              </a:spcAft>
+            </a:pPr>
+            <a:r>
+              <a:rPr sz="1600" b="0">
+                <a:solidFill>
+                  <a:srgbClr val="17212B"/>
+                </a:solidFill>
+                <a:latin typeface="Noto Sans CJK KR"/>
+              </a:rPr>
+              <a:t>• 장면이 복잡하면 객체 수를 완전히 세지 못할 수 있다.</a:t>
+            </a:r>
+          </a:p>
+          <a:p>
+            <a:pPr>
+              <a:lnSpc>
+                <a:spcPct val="115000"/>
+              </a:lnSpc>
+              <a:spcAft>
+                <a:spcPts val="800"/>
+              </a:spcAft>
+            </a:pPr>
+            <a:r>
+              <a:rPr sz="1600" b="0">
+                <a:solidFill>
+                  <a:srgbClr val="17212B"/>
+                </a:solidFill>
+                <a:latin typeface="Noto Sans CJK KR"/>
+              </a:rPr>
+              <a:t>• 정밀 bbox detector 수준의 좌표는 아니다.</a:t>
+            </a:r>
+          </a:p>
+        </p:txBody>
+      </p:sp>
+      <p:sp>
+        <p:nvSpPr>
+          <p:cNvPr id="9" name="TextBox 8"/>
+          <p:cNvSpPr txBox="1"/>
+          <p:nvPr/>
+        </p:nvSpPr>
+        <p:spPr>
+          <a:xfrm>
+            <a:off x="6400800" y="1691640"/>
+            <a:ext cx="2560320" cy="320040"/>
+          </a:xfrm>
+          <a:prstGeom prst="rect">
+            <a:avLst/>
+          </a:prstGeom>
+          <a:noFill/>
+        </p:spPr>
+        <p:txBody>
+          <a:bodyPr wrap="none">
+            <a:spAutoFit/>
+          </a:bodyPr>
+          <a:lstStyle/>
+          <a:p>
+            <a:r>
+              <a:rPr sz="2000" b="1">
+                <a:solidFill>
+                  <a:srgbClr val="17212B"/>
+                </a:solidFill>
+                <a:latin typeface="NanumSquare Bold"/>
+              </a:rPr>
+              <a:t>다음 단계</a:t>
+            </a:r>
+          </a:p>
+        </p:txBody>
+      </p:sp>
+      <p:sp>
+        <p:nvSpPr>
+          <p:cNvPr id="10" name="TextBox 9"/>
+          <p:cNvSpPr txBox="1"/>
+          <p:nvPr/>
+        </p:nvSpPr>
+        <p:spPr>
+          <a:xfrm>
+            <a:off x="6400800" y="2176272"/>
+            <a:ext cx="4663440" cy="1965960"/>
+          </a:xfrm>
+          <a:prstGeom prst="rect">
+            <a:avLst/>
+          </a:prstGeom>
+          <a:noFill/>
+        </p:spPr>
+        <p:txBody>
+          <a:bodyPr wrap="square" lIns="0" rIns="0" tIns="0" bIns="0">
+            <a:spAutoFit/>
+          </a:bodyPr>
+          <a:lstStyle/>
+          <a:p>
+            <a:pPr>
+              <a:lnSpc>
+                <a:spcPct val="115000"/>
+              </a:lnSpc>
+              <a:spcAft>
+                <a:spcPts val="800"/>
+              </a:spcAft>
+            </a:pPr>
+            <a:r>
+              <a:rPr sz="1600" b="0">
+                <a:solidFill>
+                  <a:srgbClr val="17212B"/>
+                </a:solidFill>
+                <a:latin typeface="Noto Sans CJK KR"/>
+              </a:rPr>
+              <a:t>• detector/grounding 모델을 병행해 좌표 정밀도를 높인다.</a:t>
+            </a:r>
+          </a:p>
+          <a:p>
+            <a:pPr>
+              <a:lnSpc>
+                <a:spcPct val="115000"/>
+              </a:lnSpc>
+              <a:spcAft>
+                <a:spcPts val="800"/>
+              </a:spcAft>
+            </a:pPr>
+            <a:r>
+              <a:rPr sz="1600" b="0">
+                <a:solidFill>
+                  <a:srgbClr val="17212B"/>
+                </a:solidFill>
+                <a:latin typeface="Noto Sans CJK KR"/>
+              </a:rPr>
+              <a:t>• 장애물 taxonomy를 환자이송 로봇 운영 기준으로 더 정제한다.</a:t>
+            </a:r>
+          </a:p>
+          <a:p>
+            <a:pPr>
+              <a:lnSpc>
+                <a:spcPct val="115000"/>
+              </a:lnSpc>
+              <a:spcAft>
+                <a:spcPts val="800"/>
+              </a:spcAft>
+            </a:pPr>
+            <a:r>
+              <a:rPr sz="1600" b="0">
+                <a:solidFill>
+                  <a:srgbClr val="17212B"/>
+                </a:solidFill>
+                <a:latin typeface="Noto Sans CJK KR"/>
+              </a:rPr>
+              <a:t>• OAK depth를 실시간 주행 제어와 연결한다.</a:t>
+            </a:r>
+          </a:p>
+        </p:txBody>
+      </p:sp>
+    </p:spTree>
+  </p:cSld>
+  <p:clrMapOvr>
+    <a:masterClrMapping/>
+  </p:clrMapOvr>
+</p:sld>
+</file>
+
+<file path=ppt/slides/slide12.xml><?xml version="1.0" encoding="utf-8"?>
 <p:sld xmlns:a="http://schemas.openxmlformats.org/drawingml/2006/main" xmlns:p="http://schemas.openxmlformats.org/presentationml/2006/main" xmlns:r="http://schemas.openxmlformats.org/officeDocument/2006/relationships">
   <p:cSld>
     <p:spTree>
@@ -12766,7 +13494,7 @@
                 </a:solidFill>
                 <a:latin typeface="NanumSquare Bold"/>
               </a:rPr>
-              <a:t>이 기술이 어디에서 쓰이면 좋은가</a:t>
+              <a:t>실측 거리 대비 raw / 알고리즘 적용 depth 비교</a:t>
             </a:r>
           </a:p>
         </p:txBody>
@@ -12801,7 +13529,7 @@
                 </a:solidFill>
                 <a:latin typeface="NanumBarunGothic"/>
               </a:rPr>
-              <a:t>환자이송 로봇의 실제 운영 시나리오</a:t>
+              <a:t>거리별 오차 경향을 정량적으로 비교</a:t>
             </a:r>
           </a:p>
         </p:txBody>
@@ -12815,13 +13543,13 @@
         <p:spPr>
           <a:xfrm>
             <a:off x="658368" y="164592"/>
-            <a:ext cx="1417320" cy="310896"/>
+            <a:ext cx="1508760" cy="310896"/>
           </a:xfrm>
           <a:prstGeom prst="roundRect">
             <a:avLst/>
           </a:prstGeom>
           <a:solidFill>
-            <a:srgbClr val="0F9D58"/>
+            <a:srgbClr val="7C4DFF"/>
           </a:solidFill>
           <a:ln>
             <a:noFill/>
@@ -12853,7 +13581,7 @@
                 </a:solidFill>
                 <a:latin typeface="Noto Sans CJK KR"/>
               </a:rPr>
-              <a:t>Use Cases</a:t>
+              <a:t>Depth Eval</a:t>
             </a:r>
           </a:p>
         </p:txBody>
@@ -12866,8 +13594,8 @@
         </p:nvSpPr>
         <p:spPr>
           <a:xfrm>
-            <a:off x="713232" y="1417320"/>
-            <a:ext cx="3154680" cy="4526280"/>
+            <a:off x="640080" y="1325880"/>
+            <a:ext cx="7223760" cy="4526280"/>
           </a:xfrm>
           <a:prstGeom prst="roundRect">
             <a:avLst/>
@@ -12911,17 +13639,19 @@
         </p:nvSpPr>
         <p:spPr>
           <a:xfrm>
-            <a:off x="877824" y="1600200"/>
-            <a:ext cx="1325880" cy="329184"/>
+            <a:off x="8046720" y="1325880"/>
+            <a:ext cx="3520440" cy="4526280"/>
           </a:xfrm>
           <a:prstGeom prst="roundRect">
             <a:avLst/>
           </a:prstGeom>
           <a:solidFill>
-            <a:srgbClr val="1B6EF3"/>
+            <a:srgbClr val="FFFFFF"/>
           </a:solidFill>
-          <a:ln>
-            <a:noFill/>
+          <a:ln w="12700">
+            <a:solidFill>
+              <a:srgbClr val="D8DEE8"/>
+            </a:solidFill>
           </a:ln>
         </p:spPr>
         <p:style>
@@ -12943,15 +13673,6 @@
           <a:lstStyle/>
           <a:p>
             <a:pPr algn="ctr"/>
-            <a:r>
-              <a:rPr sz="1100" b="1">
-                <a:solidFill>
-                  <a:srgbClr val="FFFFFF"/>
-                </a:solidFill>
-                <a:latin typeface="Noto Sans CJK KR"/>
-              </a:rPr>
-              <a:t>병실 출입 및 퇴실</a:t>
-            </a:r>
           </a:p>
         </p:txBody>
       </p:sp>
@@ -12963,8 +13684,8 @@
         </p:nvSpPr>
         <p:spPr>
           <a:xfrm>
-            <a:off x="877824" y="2084831"/>
-            <a:ext cx="2788920" cy="1783080"/>
+            <a:off x="960120" y="2011680"/>
+            <a:ext cx="6309360" cy="1463040"/>
           </a:xfrm>
           <a:prstGeom prst="rect">
             <a:avLst/>
@@ -12986,13 +13707,13 @@
               </a:spcAft>
             </a:pPr>
             <a:r>
-              <a:rPr sz="1400" b="0">
+              <a:rPr sz="1800" b="0">
                 <a:solidFill>
                   <a:srgbClr val="17212B"/>
                 </a:solidFill>
                 <a:latin typeface="Noto Sans CJK KR"/>
               </a:rPr>
-              <a:t>• 전방 휠체어와 IV pole을 인식하고 안전거리 확보 후 진입한다.</a:t>
+              <a:t>• depth 비교 차트용 데이터가 아직 충분하지 않다.</a:t>
             </a:r>
           </a:p>
           <a:p>
@@ -13005,170 +13726,15 @@
               </a:spcAft>
             </a:pPr>
             <a:r>
-              <a:rPr sz="1400" b="0">
+              <a:rPr sz="1800" b="0">
                 <a:solidFill>
                   <a:srgbClr val="17212B"/>
                 </a:solidFill>
                 <a:latin typeface="Noto Sans CJK KR"/>
               </a:rPr>
-              <a:t>• 병실 내부 침대 주변 가구를 보고 회전 반경을 보수적으로 잡는다.</a:t>
-            </a:r>
-          </a:p>
-        </p:txBody>
-      </p:sp>
-      <p:sp>
-        <p:nvSpPr>
-          <p:cNvPr id="8" name="TextBox 7"/>
-          <p:cNvSpPr txBox="1"/>
-          <p:nvPr/>
-        </p:nvSpPr>
-        <p:spPr>
-          <a:xfrm>
-            <a:off x="877824" y="4224528"/>
-            <a:ext cx="2788920" cy="1353312"/>
-          </a:xfrm>
-          <a:prstGeom prst="rect">
-            <a:avLst/>
-          </a:prstGeom>
-          <a:noFill/>
-        </p:spPr>
-        <p:txBody>
-          <a:bodyPr wrap="square">
-            <a:spAutoFit/>
-          </a:bodyPr>
-          <a:lstStyle/>
-          <a:p>
-            <a:pPr algn="l"/>
-            <a:r>
-              <a:rPr sz="1200" b="0">
-                <a:solidFill>
-                  <a:srgbClr val="5A6777"/>
-                </a:solidFill>
-                <a:latin typeface="NanumBarunGothic"/>
-              </a:rPr>
-              <a:t>예시 안내: “전방에 휠체어가 있습니다. 잠시 경로를 조정하겠습니다.”</a:t>
-            </a:r>
-          </a:p>
-        </p:txBody>
-      </p:sp>
-      <p:sp>
-        <p:nvSpPr>
-          <p:cNvPr id="9" name="Rounded Rectangle 8"/>
-          <p:cNvSpPr/>
-          <p:nvPr/>
-        </p:nvSpPr>
-        <p:spPr>
-          <a:xfrm>
-            <a:off x="4096512" y="1417320"/>
-            <a:ext cx="3154680" cy="4526280"/>
-          </a:xfrm>
-          <a:prstGeom prst="roundRect">
-            <a:avLst/>
-          </a:prstGeom>
-          <a:solidFill>
-            <a:srgbClr val="FFFFFF"/>
-          </a:solidFill>
-          <a:ln w="12700">
-            <a:solidFill>
-              <a:srgbClr val="D8DEE8"/>
-            </a:solidFill>
-          </a:ln>
-        </p:spPr>
-        <p:style>
-          <a:lnRef idx="1">
-            <a:schemeClr val="accent1"/>
-          </a:lnRef>
-          <a:fillRef idx="3">
-            <a:schemeClr val="accent1"/>
-          </a:fillRef>
-          <a:effectRef idx="2">
-            <a:schemeClr val="accent1"/>
-          </a:effectRef>
-          <a:fontRef idx="minor">
-            <a:schemeClr val="lt1"/>
-          </a:fontRef>
-        </p:style>
-        <p:txBody>
-          <a:bodyPr rtlCol="0" anchor="ctr"/>
-          <a:lstStyle/>
-          <a:p>
-            <a:pPr algn="ctr"/>
-          </a:p>
-        </p:txBody>
-      </p:sp>
-      <p:sp>
-        <p:nvSpPr>
-          <p:cNvPr id="10" name="Rounded Rectangle 9"/>
-          <p:cNvSpPr/>
-          <p:nvPr/>
-        </p:nvSpPr>
-        <p:spPr>
-          <a:xfrm>
-            <a:off x="4261104" y="1600200"/>
-            <a:ext cx="1325880" cy="329184"/>
-          </a:xfrm>
-          <a:prstGeom prst="roundRect">
-            <a:avLst/>
-          </a:prstGeom>
-          <a:solidFill>
-            <a:srgbClr val="E85D3F"/>
-          </a:solidFill>
-          <a:ln>
-            <a:noFill/>
-          </a:ln>
-        </p:spPr>
-        <p:style>
-          <a:lnRef idx="1">
-            <a:schemeClr val="accent1"/>
-          </a:lnRef>
-          <a:fillRef idx="3">
-            <a:schemeClr val="accent1"/>
-          </a:fillRef>
-          <a:effectRef idx="2">
-            <a:schemeClr val="accent1"/>
-          </a:effectRef>
-          <a:fontRef idx="minor">
-            <a:schemeClr val="lt1"/>
-          </a:fontRef>
-        </p:style>
-        <p:txBody>
-          <a:bodyPr rtlCol="0" anchor="ctr"/>
-          <a:lstStyle/>
-          <a:p>
-            <a:pPr algn="ctr"/>
-            <a:r>
-              <a:rPr sz="1100" b="1">
-                <a:solidFill>
-                  <a:srgbClr val="FFFFFF"/>
-                </a:solidFill>
-                <a:latin typeface="Noto Sans CJK KR"/>
-              </a:rPr>
-              <a:t>복도 주행 및 양보</a:t>
-            </a:r>
-          </a:p>
-        </p:txBody>
-      </p:sp>
-      <p:sp>
-        <p:nvSpPr>
-          <p:cNvPr id="11" name="TextBox 10"/>
-          <p:cNvSpPr txBox="1"/>
-          <p:nvPr/>
-        </p:nvSpPr>
-        <p:spPr>
-          <a:xfrm>
-            <a:off x="4261104" y="2084831"/>
-            <a:ext cx="2788920" cy="1783080"/>
-          </a:xfrm>
-          <a:prstGeom prst="rect">
-            <a:avLst/>
-          </a:prstGeom>
-          <a:noFill/>
-        </p:spPr>
-        <p:txBody>
-          <a:bodyPr wrap="square" lIns="0" rIns="0" tIns="0" bIns="0">
-            <a:spAutoFit/>
-          </a:bodyPr>
-          <a:lstStyle/>
+              <a:t>• `/home/rbiotech-server/LLM_Harnes_Support/GemmaRounter-GemmaRAGPipline/presentation/assets/depth_comparison_data.csv` 파일에 2개 이상의 거리 샘플을 채우면 자동으로 그래프가 생성된다.</a:t>
+            </a:r>
+          </a:p>
           <a:p>
             <a:pPr>
               <a:lnSpc>
@@ -13179,46 +13745,27 @@
               </a:spcAft>
             </a:pPr>
             <a:r>
-              <a:rPr sz="1400" b="0">
+              <a:rPr sz="1800" b="0">
                 <a:solidFill>
                   <a:srgbClr val="17212B"/>
                 </a:solidFill>
                 <a:latin typeface="Noto Sans CJK KR"/>
               </a:rPr>
-              <a:t>• 복도에서 의료진, 보호자, 이동식 카트를 구분해 우선순위를 판단한다.</a:t>
-            </a:r>
-          </a:p>
-          <a:p>
-            <a:pPr>
-              <a:lnSpc>
-                <a:spcPct val="115000"/>
-              </a:lnSpc>
-              <a:spcAft>
-                <a:spcPts val="800"/>
-              </a:spcAft>
-            </a:pPr>
-            <a:r>
-              <a:rPr sz="1400" b="0">
-                <a:solidFill>
-                  <a:srgbClr val="17212B"/>
-                </a:solidFill>
-                <a:latin typeface="Noto Sans CJK KR"/>
-              </a:rPr>
-              <a:t>• 사람이 지나가는 동안 일시 정지하거나 벽 쪽으로 붙는 동작에 활용할 수 있다.</a:t>
-            </a:r>
-          </a:p>
-        </p:txBody>
-      </p:sp>
-      <p:sp>
-        <p:nvSpPr>
-          <p:cNvPr id="12" name="TextBox 11"/>
+              <a:t>• 필수 컬럼: distance_m, raw_depth_mm, algorithm_depth_mm</a:t>
+            </a:r>
+          </a:p>
+        </p:txBody>
+      </p:sp>
+      <p:sp>
+        <p:nvSpPr>
+          <p:cNvPr id="8" name="TextBox 7"/>
           <p:cNvSpPr txBox="1"/>
           <p:nvPr/>
         </p:nvSpPr>
         <p:spPr>
           <a:xfrm>
-            <a:off x="4261104" y="4224528"/>
-            <a:ext cx="2788920" cy="1353312"/>
+            <a:off x="960120" y="4160520"/>
+            <a:ext cx="6217920" cy="274320"/>
           </a:xfrm>
           <a:prstGeom prst="rect">
             <a:avLst/>
@@ -13226,131 +13773,34 @@
           <a:noFill/>
         </p:spPr>
         <p:txBody>
-          <a:bodyPr wrap="square">
+          <a:bodyPr wrap="none">
             <a:spAutoFit/>
           </a:bodyPr>
           <a:lstStyle/>
           <a:p>
             <a:pPr algn="l"/>
             <a:r>
-              <a:rPr sz="1200" b="0">
+              <a:rPr sz="1100" b="0">
                 <a:solidFill>
                   <a:srgbClr val="5A6777"/>
                 </a:solidFill>
                 <a:latin typeface="NanumBarunGothic"/>
               </a:rPr>
-              <a:t>예시 안내: “파란 가운을 입은 의료진이 지나가는 중입니다. 잠시 대기 후 이동하겠습니다.”</a:t>
-            </a:r>
-          </a:p>
-        </p:txBody>
-      </p:sp>
-      <p:sp>
-        <p:nvSpPr>
-          <p:cNvPr id="13" name="Rounded Rectangle 12"/>
-          <p:cNvSpPr/>
-          <p:nvPr/>
-        </p:nvSpPr>
-        <p:spPr>
-          <a:xfrm>
-            <a:off x="7479792" y="1417320"/>
-            <a:ext cx="3154680" cy="4526280"/>
-          </a:xfrm>
-          <a:prstGeom prst="roundRect">
-            <a:avLst/>
-          </a:prstGeom>
-          <a:solidFill>
-            <a:srgbClr val="FFFFFF"/>
-          </a:solidFill>
-          <a:ln w="12700">
-            <a:solidFill>
-              <a:srgbClr val="D8DEE8"/>
-            </a:solidFill>
-          </a:ln>
-        </p:spPr>
-        <p:style>
-          <a:lnRef idx="1">
-            <a:schemeClr val="accent1"/>
-          </a:lnRef>
-          <a:fillRef idx="3">
-            <a:schemeClr val="accent1"/>
-          </a:fillRef>
-          <a:effectRef idx="2">
-            <a:schemeClr val="accent1"/>
-          </a:effectRef>
-          <a:fontRef idx="minor">
-            <a:schemeClr val="lt1"/>
-          </a:fontRef>
-        </p:style>
-        <p:txBody>
-          <a:bodyPr rtlCol="0" anchor="ctr"/>
-          <a:lstStyle/>
-          <a:p>
-            <a:pPr algn="ctr"/>
-          </a:p>
-        </p:txBody>
-      </p:sp>
-      <p:sp>
-        <p:nvSpPr>
-          <p:cNvPr id="14" name="Rounded Rectangle 13"/>
-          <p:cNvSpPr/>
-          <p:nvPr/>
-        </p:nvSpPr>
-        <p:spPr>
-          <a:xfrm>
-            <a:off x="7644383" y="1600200"/>
-            <a:ext cx="1325880" cy="329184"/>
-          </a:xfrm>
-          <a:prstGeom prst="roundRect">
-            <a:avLst/>
-          </a:prstGeom>
-          <a:solidFill>
-            <a:srgbClr val="0F9D58"/>
-          </a:solidFill>
-          <a:ln>
-            <a:noFill/>
-          </a:ln>
-        </p:spPr>
-        <p:style>
-          <a:lnRef idx="1">
-            <a:schemeClr val="accent1"/>
-          </a:lnRef>
-          <a:fillRef idx="3">
-            <a:schemeClr val="accent1"/>
-          </a:fillRef>
-          <a:effectRef idx="2">
-            <a:schemeClr val="accent1"/>
-          </a:effectRef>
-          <a:fontRef idx="minor">
-            <a:schemeClr val="lt1"/>
-          </a:fontRef>
-        </p:style>
-        <p:txBody>
-          <a:bodyPr rtlCol="0" anchor="ctr"/>
-          <a:lstStyle/>
-          <a:p>
-            <a:pPr algn="ctr"/>
-            <a:r>
-              <a:rPr sz="1100" b="1">
-                <a:solidFill>
-                  <a:srgbClr val="FFFFFF"/>
-                </a:solidFill>
-                <a:latin typeface="Noto Sans CJK KR"/>
-              </a:rPr>
-              <a:t>중앙 관제·재경로</a:t>
-            </a:r>
-          </a:p>
-        </p:txBody>
-      </p:sp>
-      <p:sp>
-        <p:nvSpPr>
-          <p:cNvPr id="15" name="TextBox 14"/>
+              <a:t>템플릿 파일: /home/rbiotech-server/LLM_Harnes_Support/GemmaRounter-GemmaRAGPipline/presentation/assets/depth_comparison_data.csv</a:t>
+            </a:r>
+          </a:p>
+        </p:txBody>
+      </p:sp>
+      <p:sp>
+        <p:nvSpPr>
+          <p:cNvPr id="9" name="TextBox 8"/>
           <p:cNvSpPr txBox="1"/>
           <p:nvPr/>
         </p:nvSpPr>
         <p:spPr>
           <a:xfrm>
-            <a:off x="7644383" y="2084831"/>
-            <a:ext cx="2788920" cy="1783080"/>
+            <a:off x="8366760" y="2057400"/>
+            <a:ext cx="2834640" cy="2011680"/>
           </a:xfrm>
           <a:prstGeom prst="rect">
             <a:avLst/>
@@ -13358,81 +13808,40 @@
           <a:noFill/>
         </p:spPr>
         <p:txBody>
-          <a:bodyPr wrap="square" lIns="0" rIns="0" tIns="0" bIns="0">
+          <a:bodyPr wrap="none">
             <a:spAutoFit/>
           </a:bodyPr>
           <a:lstStyle/>
           <a:p>
-            <a:pPr>
-              <a:lnSpc>
-                <a:spcPct val="115000"/>
-              </a:lnSpc>
-              <a:spcAft>
-                <a:spcPts val="800"/>
-              </a:spcAft>
-            </a:pPr>
-            <a:r>
-              <a:rPr sz="1400" b="0">
-                <a:solidFill>
-                  <a:srgbClr val="17212B"/>
+            <a:pPr algn="ctr"/>
+            <a:r>
+              <a:rPr sz="1800" b="1">
+                <a:solidFill>
+                  <a:srgbClr val="5A6777"/>
                 </a:solidFill>
                 <a:latin typeface="Noto Sans CJK KR"/>
               </a:rPr>
-              <a:t>• 장애물 클래스와 거리 정보를 서버로 보내 동선 혼잡도를 기록할 수 있다.</a:t>
-            </a:r>
-          </a:p>
-          <a:p>
-            <a:pPr>
-              <a:lnSpc>
-                <a:spcPct val="115000"/>
-              </a:lnSpc>
-              <a:spcAft>
-                <a:spcPts val="800"/>
-              </a:spcAft>
-            </a:pPr>
-            <a:r>
-              <a:rPr sz="1400" b="0">
-                <a:solidFill>
-                  <a:srgbClr val="17212B"/>
+              <a:t>CSV를 채우면</a:t>
+            </a:r>
+            <a:br/>
+            <a:r>
+              <a:rPr sz="1800" b="1">
+                <a:solidFill>
+                  <a:srgbClr val="5A6777"/>
                 </a:solidFill>
                 <a:latin typeface="Noto Sans CJK KR"/>
               </a:rPr>
-              <a:t>• 병동별 잦은 장애물 패턴을 보고 재경로 정책을 보강할 수 있다.</a:t>
-            </a:r>
-          </a:p>
-        </p:txBody>
-      </p:sp>
-      <p:sp>
-        <p:nvSpPr>
-          <p:cNvPr id="16" name="TextBox 15"/>
-          <p:cNvSpPr txBox="1"/>
-          <p:nvPr/>
-        </p:nvSpPr>
-        <p:spPr>
-          <a:xfrm>
-            <a:off x="7644383" y="4224528"/>
-            <a:ext cx="2788920" cy="1353312"/>
-          </a:xfrm>
-          <a:prstGeom prst="rect">
-            <a:avLst/>
-          </a:prstGeom>
-          <a:noFill/>
-        </p:spPr>
-        <p:txBody>
-          <a:bodyPr wrap="square">
-            <a:spAutoFit/>
-          </a:bodyPr>
-          <a:lstStyle/>
-          <a:p>
-            <a:pPr algn="l"/>
-            <a:r>
-              <a:rPr sz="1200" b="0">
+              <a:t>이 영역에 꺾은선그래프와</a:t>
+            </a:r>
+            <a:br/>
+            <a:r>
+              <a:rPr sz="1800" b="1">
                 <a:solidFill>
                   <a:srgbClr val="5A6777"/>
                 </a:solidFill>
-                <a:latin typeface="NanumBarunGothic"/>
-              </a:rPr>
-              <a:t>예시 안내: “전방 2.8m 지점에 이동 장애물이 있습니다. 우회 경로를 탐색합니다.”</a:t>
+                <a:latin typeface="Noto Sans CJK KR"/>
+              </a:rPr>
+              <a:t>비교 표가 생성됩니다.</a:t>
             </a:r>
           </a:p>
         </p:txBody>

</xml_diff>